<commit_message>
fix(aula6): cabe código dos slides Bloco 3/4 no painel
Reduz altura do container e a fonte para o texto não invadir o rodapé.

Co-authored-by: Cursor <cursoragent@cursor.com>
</commit_message>
<xml_diff>
--- a/assets/docs/aulas/aula06_mercado_loja_etica_slides.pptx
+++ b/assets/docs/aulas/aula06_mercado_loja_etica_slides.pptx
@@ -4068,8 +4068,8 @@
         </p:nvSpPr>
         <p:spPr>
           <a:xfrm>
-            <a:off x="365760" y="868680"/>
-            <a:ext cx="8412480" cy="3840480"/>
+            <a:off x="365760" y="804672"/>
+            <a:ext cx="8412480" cy="3657600"/>
           </a:xfrm>
           <a:prstGeom prst="roundRect">
             <a:avLst/>
@@ -4113,8 +4113,8 @@
         </p:nvSpPr>
         <p:spPr>
           <a:xfrm>
-            <a:off x="502920" y="960120"/>
-            <a:ext cx="8138160" cy="3611880"/>
+            <a:off x="502920" y="896112"/>
+            <a:ext cx="8138160" cy="3429000"/>
           </a:xfrm>
           <a:prstGeom prst="rect">
             <a:avLst/>
@@ -4128,6 +4128,9 @@
           <a:lstStyle/>
           <a:p>
             <a:pPr algn="l">
+              <a:lnSpc>
+                <a:spcPct val="100000"/>
+              </a:lnSpc>
               <a:spcBef>
                 <a:spcPts val="0"/>
               </a:spcBef>
@@ -4136,7 +4139,7 @@
               </a:spcAft>
             </a:pPr>
             <a:r>
-              <a:rPr sz="1000" b="0">
+              <a:rPr sz="900" b="0">
                 <a:solidFill>
                   <a:srgbClr val="ECE1D1"/>
                 </a:solidFill>
@@ -4149,6 +4152,9 @@
           </a:p>
           <a:p>
             <a:pPr algn="l">
+              <a:lnSpc>
+                <a:spcPct val="100000"/>
+              </a:lnSpc>
               <a:spcBef>
                 <a:spcPts val="0"/>
               </a:spcBef>
@@ -4157,7 +4163,7 @@
               </a:spcAft>
             </a:pPr>
             <a:r>
-              <a:rPr sz="1000" b="0">
+              <a:rPr sz="900" b="0">
                 <a:solidFill>
                   <a:srgbClr val="ECE1D1"/>
                 </a:solidFill>
@@ -4165,11 +4171,14 @@
                 <a:cs typeface="Consolas"/>
                 <a:ea typeface="Consolas"/>
               </a:rPr>
-              <a:t> </a:t>
+              <a:t>var moedas: int = 10</a:t>
             </a:r>
           </a:p>
           <a:p>
             <a:pPr algn="l">
+              <a:lnSpc>
+                <a:spcPct val="100000"/>
+              </a:lnSpc>
               <a:spcBef>
                 <a:spcPts val="0"/>
               </a:spcBef>
@@ -4178,7 +4187,7 @@
               </a:spcAft>
             </a:pPr>
             <a:r>
-              <a:rPr sz="1000" b="0">
+              <a:rPr sz="900" b="0">
                 <a:solidFill>
                   <a:srgbClr val="ECE1D1"/>
                 </a:solidFill>
@@ -4186,11 +4195,14 @@
                 <a:cs typeface="Consolas"/>
                 <a:ea typeface="Consolas"/>
               </a:rPr>
-              <a:t>var moedas: int = 10</a:t>
+              <a:t>var tem_chapeu: bool = false</a:t>
             </a:r>
           </a:p>
           <a:p>
             <a:pPr algn="l">
+              <a:lnSpc>
+                <a:spcPct val="100000"/>
+              </a:lnSpc>
               <a:spcBef>
                 <a:spcPts val="0"/>
               </a:spcBef>
@@ -4199,7 +4211,7 @@
               </a:spcAft>
             </a:pPr>
             <a:r>
-              <a:rPr sz="1000" b="0">
+              <a:rPr sz="900" b="0">
                 <a:solidFill>
                   <a:srgbClr val="ECE1D1"/>
                 </a:solidFill>
@@ -4207,11 +4219,14 @@
                 <a:cs typeface="Consolas"/>
                 <a:ea typeface="Consolas"/>
               </a:rPr>
-              <a:t>var tem_chapeu: bool = false</a:t>
+              <a:t>var tem_capa: bool = false</a:t>
             </a:r>
           </a:p>
           <a:p>
             <a:pPr algn="l">
+              <a:lnSpc>
+                <a:spcPct val="100000"/>
+              </a:lnSpc>
               <a:spcBef>
                 <a:spcPts val="0"/>
               </a:spcBef>
@@ -4220,7 +4235,7 @@
               </a:spcAft>
             </a:pPr>
             <a:r>
-              <a:rPr sz="1000" b="0">
+              <a:rPr sz="900" b="0">
                 <a:solidFill>
                   <a:srgbClr val="ECE1D1"/>
                 </a:solidFill>
@@ -4228,11 +4243,14 @@
                 <a:cs typeface="Consolas"/>
                 <a:ea typeface="Consolas"/>
               </a:rPr>
-              <a:t>var tem_capa: bool = false</a:t>
+              <a:t>var tem_aura: bool = false</a:t>
             </a:r>
           </a:p>
           <a:p>
             <a:pPr algn="l">
+              <a:lnSpc>
+                <a:spcPct val="100000"/>
+              </a:lnSpc>
               <a:spcBef>
                 <a:spcPts val="0"/>
               </a:spcBef>
@@ -4241,7 +4259,7 @@
               </a:spcAft>
             </a:pPr>
             <a:r>
-              <a:rPr sz="1000" b="0">
+              <a:rPr sz="900" b="0">
                 <a:solidFill>
                   <a:srgbClr val="ECE1D1"/>
                 </a:solidFill>
@@ -4249,11 +4267,14 @@
                 <a:cs typeface="Consolas"/>
                 <a:ea typeface="Consolas"/>
               </a:rPr>
-              <a:t>var tem_aura: bool = false</a:t>
+              <a:t>const PRECO_CHAPEU: int = 5</a:t>
             </a:r>
           </a:p>
           <a:p>
             <a:pPr algn="l">
+              <a:lnSpc>
+                <a:spcPct val="100000"/>
+              </a:lnSpc>
               <a:spcBef>
                 <a:spcPts val="0"/>
               </a:spcBef>
@@ -4262,7 +4283,7 @@
               </a:spcAft>
             </a:pPr>
             <a:r>
-              <a:rPr sz="1000" b="0">
+              <a:rPr sz="900" b="0">
                 <a:solidFill>
                   <a:srgbClr val="ECE1D1"/>
                 </a:solidFill>
@@ -4270,11 +4291,14 @@
                 <a:cs typeface="Consolas"/>
                 <a:ea typeface="Consolas"/>
               </a:rPr>
-              <a:t>const PRECO_CHAPEU: int = 5</a:t>
+              <a:t>const PRECO_CAPA: int = 12</a:t>
             </a:r>
           </a:p>
           <a:p>
             <a:pPr algn="l">
+              <a:lnSpc>
+                <a:spcPct val="100000"/>
+              </a:lnSpc>
               <a:spcBef>
                 <a:spcPts val="0"/>
               </a:spcBef>
@@ -4283,7 +4307,7 @@
               </a:spcAft>
             </a:pPr>
             <a:r>
-              <a:rPr sz="1000" b="0">
+              <a:rPr sz="900" b="0">
                 <a:solidFill>
                   <a:srgbClr val="ECE1D1"/>
                 </a:solidFill>
@@ -4291,11 +4315,14 @@
                 <a:cs typeface="Consolas"/>
                 <a:ea typeface="Consolas"/>
               </a:rPr>
-              <a:t>const PRECO_CAPA: int = 12</a:t>
+              <a:t>const PRECO_AURA: int = 20</a:t>
             </a:r>
           </a:p>
           <a:p>
             <a:pPr algn="l">
+              <a:lnSpc>
+                <a:spcPct val="100000"/>
+              </a:lnSpc>
               <a:spcBef>
                 <a:spcPts val="0"/>
               </a:spcBef>
@@ -4304,7 +4331,7 @@
               </a:spcAft>
             </a:pPr>
             <a:r>
-              <a:rPr sz="1000" b="0">
+              <a:rPr sz="900" b="0">
                 <a:solidFill>
                   <a:srgbClr val="ECE1D1"/>
                 </a:solidFill>
@@ -4312,11 +4339,14 @@
                 <a:cs typeface="Consolas"/>
                 <a:ea typeface="Consolas"/>
               </a:rPr>
-              <a:t>const PRECO_AURA: int = 20</a:t>
+              <a:t>const GANHO_FASE: int = 5</a:t>
             </a:r>
           </a:p>
           <a:p>
             <a:pPr algn="l">
+              <a:lnSpc>
+                <a:spcPct val="100000"/>
+              </a:lnSpc>
               <a:spcBef>
                 <a:spcPts val="0"/>
               </a:spcBef>
@@ -4325,7 +4355,7 @@
               </a:spcAft>
             </a:pPr>
             <a:r>
-              <a:rPr sz="1000" b="0">
+              <a:rPr sz="900" b="0">
                 <a:solidFill>
                   <a:srgbClr val="ECE1D1"/>
                 </a:solidFill>
@@ -4333,11 +4363,14 @@
                 <a:cs typeface="Consolas"/>
                 <a:ea typeface="Consolas"/>
               </a:rPr>
-              <a:t>const GANHO_FASE: int = 5</a:t>
+              <a:t>@onready var label_moedas: Label = $PanelContainer/MarginContainer/VBoxContainer/Moedas</a:t>
             </a:r>
           </a:p>
           <a:p>
             <a:pPr algn="l">
+              <a:lnSpc>
+                <a:spcPct val="100000"/>
+              </a:lnSpc>
               <a:spcBef>
                 <a:spcPts val="0"/>
               </a:spcBef>
@@ -4346,7 +4379,7 @@
               </a:spcAft>
             </a:pPr>
             <a:r>
-              <a:rPr sz="1000" b="0">
+              <a:rPr sz="900" b="0">
                 <a:solidFill>
                   <a:srgbClr val="ECE1D1"/>
                 </a:solidFill>
@@ -4354,11 +4387,14 @@
                 <a:cs typeface="Consolas"/>
                 <a:ea typeface="Consolas"/>
               </a:rPr>
-              <a:t> </a:t>
+              <a:t>@onready var label_status: Label = $PanelContainer/MarginContainer/VBoxContainer/Status</a:t>
             </a:r>
           </a:p>
           <a:p>
             <a:pPr algn="l">
+              <a:lnSpc>
+                <a:spcPct val="100000"/>
+              </a:lnSpc>
               <a:spcBef>
                 <a:spcPts val="0"/>
               </a:spcBef>
@@ -4367,7 +4403,7 @@
               </a:spcAft>
             </a:pPr>
             <a:r>
-              <a:rPr sz="1000" b="0">
+              <a:rPr sz="900" b="0">
                 <a:solidFill>
                   <a:srgbClr val="ECE1D1"/>
                 </a:solidFill>
@@ -4375,11 +4411,14 @@
                 <a:cs typeface="Consolas"/>
                 <a:ea typeface="Consolas"/>
               </a:rPr>
-              <a:t>@onready var label_moedas: Label = $PanelContainer/MarginContainer/VBoxContainer/Moedas</a:t>
+              <a:t>@onready var btn_chapeu: Button = $PanelContainer/MarginContainer/VBoxContainer/Chapeu/HBoxContainer/Button</a:t>
             </a:r>
           </a:p>
           <a:p>
             <a:pPr algn="l">
+              <a:lnSpc>
+                <a:spcPct val="100000"/>
+              </a:lnSpc>
               <a:spcBef>
                 <a:spcPts val="0"/>
               </a:spcBef>
@@ -4388,7 +4427,7 @@
               </a:spcAft>
             </a:pPr>
             <a:r>
-              <a:rPr sz="1000" b="0">
+              <a:rPr sz="900" b="0">
                 <a:solidFill>
                   <a:srgbClr val="ECE1D1"/>
                 </a:solidFill>
@@ -4396,11 +4435,14 @@
                 <a:cs typeface="Consolas"/>
                 <a:ea typeface="Consolas"/>
               </a:rPr>
-              <a:t>@onready var label_status: Label = $PanelContainer/MarginContainer/VBoxContainer/Status</a:t>
+              <a:t>@onready var btn_capa: Button = $PanelContainer/MarginContainer/VBoxContainer/Capa/HBoxContainer/Button</a:t>
             </a:r>
           </a:p>
           <a:p>
             <a:pPr algn="l">
+              <a:lnSpc>
+                <a:spcPct val="100000"/>
+              </a:lnSpc>
               <a:spcBef>
                 <a:spcPts val="0"/>
               </a:spcBef>
@@ -4409,7 +4451,7 @@
               </a:spcAft>
             </a:pPr>
             <a:r>
-              <a:rPr sz="1000" b="0">
+              <a:rPr sz="900" b="0">
                 <a:solidFill>
                   <a:srgbClr val="ECE1D1"/>
                 </a:solidFill>
@@ -4417,11 +4459,14 @@
                 <a:cs typeface="Consolas"/>
                 <a:ea typeface="Consolas"/>
               </a:rPr>
-              <a:t>@onready var btn_chapeu: Button = $PanelContainer/MarginContainer/VBoxContainer/Chapeu/HBoxContainer/Button</a:t>
+              <a:t>@onready var btn_aura: Button = $PanelContainer/MarginContainer/VBoxContainer/Aura/HBoxContainer/Button</a:t>
             </a:r>
           </a:p>
           <a:p>
             <a:pPr algn="l">
+              <a:lnSpc>
+                <a:spcPct val="100000"/>
+              </a:lnSpc>
               <a:spcBef>
                 <a:spcPts val="0"/>
               </a:spcBef>
@@ -4430,7 +4475,7 @@
               </a:spcAft>
             </a:pPr>
             <a:r>
-              <a:rPr sz="1000" b="0">
+              <a:rPr sz="900" b="0">
                 <a:solidFill>
                   <a:srgbClr val="ECE1D1"/>
                 </a:solidFill>
@@ -4438,11 +4483,14 @@
                 <a:cs typeface="Consolas"/>
                 <a:ea typeface="Consolas"/>
               </a:rPr>
-              <a:t>@onready var btn_capa: Button = $PanelContainer/MarginContainer/VBoxContainer/Capa/HBoxContainer/Button</a:t>
+              <a:t>func _ready() -&gt; void:</a:t>
             </a:r>
           </a:p>
           <a:p>
             <a:pPr algn="l">
+              <a:lnSpc>
+                <a:spcPct val="100000"/>
+              </a:lnSpc>
               <a:spcBef>
                 <a:spcPts val="0"/>
               </a:spcBef>
@@ -4451,7 +4499,7 @@
               </a:spcAft>
             </a:pPr>
             <a:r>
-              <a:rPr sz="1000" b="0">
+              <a:rPr sz="900" b="0">
                 <a:solidFill>
                   <a:srgbClr val="ECE1D1"/>
                 </a:solidFill>
@@ -4459,11 +4507,14 @@
                 <a:cs typeface="Consolas"/>
                 <a:ea typeface="Consolas"/>
               </a:rPr>
-              <a:t>@onready var btn_aura: Button = $PanelContainer/MarginContainer/VBoxContainer/Aura/HBoxContainer/Button</a:t>
+              <a:t>	_atualizar_hud()</a:t>
             </a:r>
           </a:p>
           <a:p>
             <a:pPr algn="l">
+              <a:lnSpc>
+                <a:spcPct val="100000"/>
+              </a:lnSpc>
               <a:spcBef>
                 <a:spcPts val="0"/>
               </a:spcBef>
@@ -4472,7 +4523,7 @@
               </a:spcAft>
             </a:pPr>
             <a:r>
-              <a:rPr sz="1000" b="0">
+              <a:rPr sz="900" b="0">
                 <a:solidFill>
                   <a:srgbClr val="ECE1D1"/>
                 </a:solidFill>
@@ -4480,11 +4531,14 @@
                 <a:cs typeface="Consolas"/>
                 <a:ea typeface="Consolas"/>
               </a:rPr>
-              <a:t> </a:t>
+              <a:t>	label_status.text = "Bem-vindo. Só moedas ganhas jogando."</a:t>
             </a:r>
           </a:p>
           <a:p>
             <a:pPr algn="l">
+              <a:lnSpc>
+                <a:spcPct val="100000"/>
+              </a:lnSpc>
               <a:spcBef>
                 <a:spcPts val="0"/>
               </a:spcBef>
@@ -4493,7 +4547,7 @@
               </a:spcAft>
             </a:pPr>
             <a:r>
-              <a:rPr sz="1000" b="0">
+              <a:rPr sz="900" b="0">
                 <a:solidFill>
                   <a:srgbClr val="ECE1D1"/>
                 </a:solidFill>
@@ -4501,11 +4555,14 @@
                 <a:cs typeface="Consolas"/>
                 <a:ea typeface="Consolas"/>
               </a:rPr>
-              <a:t>func _ready() -&gt; void:</a:t>
+              <a:t>func _atualizar_hud() -&gt; void:</a:t>
             </a:r>
           </a:p>
           <a:p>
             <a:pPr algn="l">
+              <a:lnSpc>
+                <a:spcPct val="100000"/>
+              </a:lnSpc>
               <a:spcBef>
                 <a:spcPts val="0"/>
               </a:spcBef>
@@ -4514,7 +4571,7 @@
               </a:spcAft>
             </a:pPr>
             <a:r>
-              <a:rPr sz="1000" b="0">
+              <a:rPr sz="900" b="0">
                 <a:solidFill>
                   <a:srgbClr val="ECE1D1"/>
                 </a:solidFill>
@@ -4522,11 +4579,14 @@
                 <a:cs typeface="Consolas"/>
                 <a:ea typeface="Consolas"/>
               </a:rPr>
-              <a:t>    _atualizar_hud()</a:t>
+              <a:t>	label_moedas.text = "Moedas: %d" % moedas</a:t>
             </a:r>
           </a:p>
           <a:p>
             <a:pPr algn="l">
+              <a:lnSpc>
+                <a:spcPct val="100000"/>
+              </a:lnSpc>
               <a:spcBef>
                 <a:spcPts val="0"/>
               </a:spcBef>
@@ -4535,7 +4595,7 @@
               </a:spcAft>
             </a:pPr>
             <a:r>
-              <a:rPr sz="1000" b="0">
+              <a:rPr sz="900" b="0">
                 <a:solidFill>
                   <a:srgbClr val="ECE1D1"/>
                 </a:solidFill>
@@ -4543,11 +4603,14 @@
                 <a:cs typeface="Consolas"/>
                 <a:ea typeface="Consolas"/>
               </a:rPr>
-              <a:t>    label_status.text = "Bem-vindo. Só moedas ganhas jogando."</a:t>
+              <a:t>func _on_btn_ganhar_moedas_pressed() -&gt; void:</a:t>
             </a:r>
           </a:p>
           <a:p>
             <a:pPr algn="l">
+              <a:lnSpc>
+                <a:spcPct val="100000"/>
+              </a:lnSpc>
               <a:spcBef>
                 <a:spcPts val="0"/>
               </a:spcBef>
@@ -4556,7 +4619,7 @@
               </a:spcAft>
             </a:pPr>
             <a:r>
-              <a:rPr sz="1000" b="0">
+              <a:rPr sz="900" b="0">
                 <a:solidFill>
                   <a:srgbClr val="ECE1D1"/>
                 </a:solidFill>
@@ -4564,11 +4627,14 @@
                 <a:cs typeface="Consolas"/>
                 <a:ea typeface="Consolas"/>
               </a:rPr>
-              <a:t> </a:t>
+              <a:t>	moedas += GANHO_FASE</a:t>
             </a:r>
           </a:p>
           <a:p>
             <a:pPr algn="l">
+              <a:lnSpc>
+                <a:spcPct val="100000"/>
+              </a:lnSpc>
               <a:spcBef>
                 <a:spcPts val="0"/>
               </a:spcBef>
@@ -4577,7 +4643,7 @@
               </a:spcAft>
             </a:pPr>
             <a:r>
-              <a:rPr sz="1000" b="0">
+              <a:rPr sz="900" b="0">
                 <a:solidFill>
                   <a:srgbClr val="ECE1D1"/>
                 </a:solidFill>
@@ -4585,11 +4651,14 @@
                 <a:cs typeface="Consolas"/>
                 <a:ea typeface="Consolas"/>
               </a:rPr>
-              <a:t>func _atualizar_hud() -&gt; void:</a:t>
+              <a:t>	label_status.text = "Você coletou +%d moedas na fase." % GANHO_FASE</a:t>
             </a:r>
           </a:p>
           <a:p>
             <a:pPr algn="l">
+              <a:lnSpc>
+                <a:spcPct val="100000"/>
+              </a:lnSpc>
               <a:spcBef>
                 <a:spcPts val="0"/>
               </a:spcBef>
@@ -4598,7 +4667,7 @@
               </a:spcAft>
             </a:pPr>
             <a:r>
-              <a:rPr sz="1000" b="0">
+              <a:rPr sz="900" b="0">
                 <a:solidFill>
                   <a:srgbClr val="ECE1D1"/>
                 </a:solidFill>
@@ -4606,112 +4675,7 @@
                 <a:cs typeface="Consolas"/>
                 <a:ea typeface="Consolas"/>
               </a:rPr>
-              <a:t>    label_moedas.text = "Moedas: %d" % moedas</a:t>
-            </a:r>
-          </a:p>
-          <a:p>
-            <a:pPr algn="l">
-              <a:spcBef>
-                <a:spcPts val="0"/>
-              </a:spcBef>
-              <a:spcAft>
-                <a:spcPts val="0"/>
-              </a:spcAft>
-            </a:pPr>
-            <a:r>
-              <a:rPr sz="1000" b="0">
-                <a:solidFill>
-                  <a:srgbClr val="ECE1D1"/>
-                </a:solidFill>
-                <a:latin typeface="Consolas"/>
-                <a:cs typeface="Consolas"/>
-                <a:ea typeface="Consolas"/>
-              </a:rPr>
-              <a:t> </a:t>
-            </a:r>
-          </a:p>
-          <a:p>
-            <a:pPr algn="l">
-              <a:spcBef>
-                <a:spcPts val="0"/>
-              </a:spcBef>
-              <a:spcAft>
-                <a:spcPts val="0"/>
-              </a:spcAft>
-            </a:pPr>
-            <a:r>
-              <a:rPr sz="1000" b="0">
-                <a:solidFill>
-                  <a:srgbClr val="ECE1D1"/>
-                </a:solidFill>
-                <a:latin typeface="Consolas"/>
-                <a:cs typeface="Consolas"/>
-                <a:ea typeface="Consolas"/>
-              </a:rPr>
-              <a:t>func _on_btn_ganhar_moedas_pressed() -&gt; void:</a:t>
-            </a:r>
-          </a:p>
-          <a:p>
-            <a:pPr algn="l">
-              <a:spcBef>
-                <a:spcPts val="0"/>
-              </a:spcBef>
-              <a:spcAft>
-                <a:spcPts val="0"/>
-              </a:spcAft>
-            </a:pPr>
-            <a:r>
-              <a:rPr sz="1000" b="0">
-                <a:solidFill>
-                  <a:srgbClr val="ECE1D1"/>
-                </a:solidFill>
-                <a:latin typeface="Consolas"/>
-                <a:cs typeface="Consolas"/>
-                <a:ea typeface="Consolas"/>
-              </a:rPr>
-              <a:t>    moedas += GANHO_FASE</a:t>
-            </a:r>
-          </a:p>
-          <a:p>
-            <a:pPr algn="l">
-              <a:spcBef>
-                <a:spcPts val="0"/>
-              </a:spcBef>
-              <a:spcAft>
-                <a:spcPts val="0"/>
-              </a:spcAft>
-            </a:pPr>
-            <a:r>
-              <a:rPr sz="1000" b="0">
-                <a:solidFill>
-                  <a:srgbClr val="ECE1D1"/>
-                </a:solidFill>
-                <a:latin typeface="Consolas"/>
-                <a:cs typeface="Consolas"/>
-                <a:ea typeface="Consolas"/>
-              </a:rPr>
-              <a:t>    label_status.text = "Você coletou +%d moedas na fase." % GANHO_FASE</a:t>
-            </a:r>
-          </a:p>
-          <a:p>
-            <a:pPr algn="l">
-              <a:spcBef>
-                <a:spcPts val="0"/>
-              </a:spcBef>
-              <a:spcAft>
-                <a:spcPts val="0"/>
-              </a:spcAft>
-            </a:pPr>
-            <a:r>
-              <a:rPr sz="1000" b="0">
-                <a:solidFill>
-                  <a:srgbClr val="ECE1D1"/>
-                </a:solidFill>
-                <a:latin typeface="Consolas"/>
-                <a:cs typeface="Consolas"/>
-                <a:ea typeface="Consolas"/>
-              </a:rPr>
-              <a:t>    _atualizar_hud()</a:t>
+              <a:t>	_atualizar_hud()</a:t>
             </a:r>
           </a:p>
         </p:txBody>
@@ -5009,8 +4973,8 @@
         </p:nvSpPr>
         <p:spPr>
           <a:xfrm>
-            <a:off x="365760" y="868680"/>
-            <a:ext cx="8412480" cy="3840480"/>
+            <a:off x="365760" y="804672"/>
+            <a:ext cx="8412480" cy="3657600"/>
           </a:xfrm>
           <a:prstGeom prst="roundRect">
             <a:avLst/>
@@ -5054,8 +5018,8 @@
         </p:nvSpPr>
         <p:spPr>
           <a:xfrm>
-            <a:off x="502920" y="960120"/>
-            <a:ext cx="8138160" cy="3611880"/>
+            <a:off x="502920" y="896112"/>
+            <a:ext cx="8138160" cy="3429000"/>
           </a:xfrm>
           <a:prstGeom prst="rect">
             <a:avLst/>
@@ -5069,6 +5033,9 @@
           <a:lstStyle/>
           <a:p>
             <a:pPr algn="l">
+              <a:lnSpc>
+                <a:spcPct val="100000"/>
+              </a:lnSpc>
               <a:spcBef>
                 <a:spcPts val="0"/>
               </a:spcBef>
@@ -5077,7 +5044,7 @@
               </a:spcAft>
             </a:pPr>
             <a:r>
-              <a:rPr sz="1200" b="0">
+              <a:rPr sz="1100" b="0">
                 <a:solidFill>
                   <a:srgbClr val="ECE1D1"/>
                 </a:solidFill>
@@ -5090,6 +5057,9 @@
           </a:p>
           <a:p>
             <a:pPr algn="l">
+              <a:lnSpc>
+                <a:spcPct val="100000"/>
+              </a:lnSpc>
               <a:spcBef>
                 <a:spcPts val="0"/>
               </a:spcBef>
@@ -5098,7 +5068,7 @@
               </a:spcAft>
             </a:pPr>
             <a:r>
-              <a:rPr sz="1200" b="0">
+              <a:rPr sz="1100" b="0">
                 <a:solidFill>
                   <a:srgbClr val="ECE1D1"/>
                 </a:solidFill>
@@ -5106,11 +5076,14 @@
                 <a:cs typeface="Consolas"/>
                 <a:ea typeface="Consolas"/>
               </a:rPr>
-              <a:t>    if tem_chapeu:</a:t>
+              <a:t>	if tem_chapeu:</a:t>
             </a:r>
           </a:p>
           <a:p>
             <a:pPr algn="l">
+              <a:lnSpc>
+                <a:spcPct val="100000"/>
+              </a:lnSpc>
               <a:spcBef>
                 <a:spcPts val="0"/>
               </a:spcBef>
@@ -5119,7 +5092,7 @@
               </a:spcAft>
             </a:pPr>
             <a:r>
-              <a:rPr sz="1200" b="0">
+              <a:rPr sz="1100" b="0">
                 <a:solidFill>
                   <a:srgbClr val="ECE1D1"/>
                 </a:solidFill>
@@ -5127,11 +5100,14 @@
                 <a:cs typeface="Consolas"/>
                 <a:ea typeface="Consolas"/>
               </a:rPr>
-              <a:t>        label_status.text = "Você já tem chapéu."</a:t>
+              <a:t>		label_status.text = "Você já tem chapéu."</a:t>
             </a:r>
           </a:p>
           <a:p>
             <a:pPr algn="l">
+              <a:lnSpc>
+                <a:spcPct val="100000"/>
+              </a:lnSpc>
               <a:spcBef>
                 <a:spcPts val="0"/>
               </a:spcBef>
@@ -5140,7 +5116,7 @@
               </a:spcAft>
             </a:pPr>
             <a:r>
-              <a:rPr sz="1200" b="0">
+              <a:rPr sz="1100" b="0">
                 <a:solidFill>
                   <a:srgbClr val="ECE1D1"/>
                 </a:solidFill>
@@ -5148,11 +5124,14 @@
                 <a:cs typeface="Consolas"/>
                 <a:ea typeface="Consolas"/>
               </a:rPr>
-              <a:t>        return</a:t>
+              <a:t>		return</a:t>
             </a:r>
           </a:p>
           <a:p>
             <a:pPr algn="l">
+              <a:lnSpc>
+                <a:spcPct val="100000"/>
+              </a:lnSpc>
               <a:spcBef>
                 <a:spcPts val="0"/>
               </a:spcBef>
@@ -5161,7 +5140,7 @@
               </a:spcAft>
             </a:pPr>
             <a:r>
-              <a:rPr sz="1200" b="0">
+              <a:rPr sz="1100" b="0">
                 <a:solidFill>
                   <a:srgbClr val="ECE1D1"/>
                 </a:solidFill>
@@ -5169,11 +5148,14 @@
                 <a:cs typeface="Consolas"/>
                 <a:ea typeface="Consolas"/>
               </a:rPr>
-              <a:t>    if moedas &lt; PRECO_CHAPEU:</a:t>
+              <a:t>	if moedas &lt; PRECO_CHAPEU:</a:t>
             </a:r>
           </a:p>
           <a:p>
             <a:pPr algn="l">
+              <a:lnSpc>
+                <a:spcPct val="100000"/>
+              </a:lnSpc>
               <a:spcBef>
                 <a:spcPts val="0"/>
               </a:spcBef>
@@ -5182,7 +5164,7 @@
               </a:spcAft>
             </a:pPr>
             <a:r>
-              <a:rPr sz="1200" b="0">
+              <a:rPr sz="1100" b="0">
                 <a:solidFill>
                   <a:srgbClr val="ECE1D1"/>
                 </a:solidFill>
@@ -5190,11 +5172,14 @@
                 <a:cs typeface="Consolas"/>
                 <a:ea typeface="Consolas"/>
               </a:rPr>
-              <a:t>        label_status.text = "Moedas insuficientes."</a:t>
+              <a:t>		label_status.text = "Moedas insuficientes."</a:t>
             </a:r>
           </a:p>
           <a:p>
             <a:pPr algn="l">
+              <a:lnSpc>
+                <a:spcPct val="100000"/>
+              </a:lnSpc>
               <a:spcBef>
                 <a:spcPts val="0"/>
               </a:spcBef>
@@ -5203,7 +5188,7 @@
               </a:spcAft>
             </a:pPr>
             <a:r>
-              <a:rPr sz="1200" b="0">
+              <a:rPr sz="1100" b="0">
                 <a:solidFill>
                   <a:srgbClr val="ECE1D1"/>
                 </a:solidFill>
@@ -5211,11 +5196,14 @@
                 <a:cs typeface="Consolas"/>
                 <a:ea typeface="Consolas"/>
               </a:rPr>
-              <a:t>        return</a:t>
+              <a:t>		return</a:t>
             </a:r>
           </a:p>
           <a:p>
             <a:pPr algn="l">
+              <a:lnSpc>
+                <a:spcPct val="100000"/>
+              </a:lnSpc>
               <a:spcBef>
                 <a:spcPts val="0"/>
               </a:spcBef>
@@ -5224,7 +5212,7 @@
               </a:spcAft>
             </a:pPr>
             <a:r>
-              <a:rPr sz="1200" b="0">
+              <a:rPr sz="1100" b="0">
                 <a:solidFill>
                   <a:srgbClr val="ECE1D1"/>
                 </a:solidFill>
@@ -5232,11 +5220,14 @@
                 <a:cs typeface="Consolas"/>
                 <a:ea typeface="Consolas"/>
               </a:rPr>
-              <a:t>    moedas -= PRECO_CHAPEU</a:t>
+              <a:t>	moedas -= PRECO_CHAPEU</a:t>
             </a:r>
           </a:p>
           <a:p>
             <a:pPr algn="l">
+              <a:lnSpc>
+                <a:spcPct val="100000"/>
+              </a:lnSpc>
               <a:spcBef>
                 <a:spcPts val="0"/>
               </a:spcBef>
@@ -5245,7 +5236,7 @@
               </a:spcAft>
             </a:pPr>
             <a:r>
-              <a:rPr sz="1200" b="0">
+              <a:rPr sz="1100" b="0">
                 <a:solidFill>
                   <a:srgbClr val="ECE1D1"/>
                 </a:solidFill>
@@ -5253,11 +5244,14 @@
                 <a:cs typeface="Consolas"/>
                 <a:ea typeface="Consolas"/>
               </a:rPr>
-              <a:t>    tem_chapeu = true</a:t>
+              <a:t>	tem_chapeu = true</a:t>
             </a:r>
           </a:p>
           <a:p>
             <a:pPr algn="l">
+              <a:lnSpc>
+                <a:spcPct val="100000"/>
+              </a:lnSpc>
               <a:spcBef>
                 <a:spcPts val="0"/>
               </a:spcBef>
@@ -5266,7 +5260,7 @@
               </a:spcAft>
             </a:pPr>
             <a:r>
-              <a:rPr sz="1200" b="0">
+              <a:rPr sz="1100" b="0">
                 <a:solidFill>
                   <a:srgbClr val="ECE1D1"/>
                 </a:solidFill>
@@ -5274,11 +5268,14 @@
                 <a:cs typeface="Consolas"/>
                 <a:ea typeface="Consolas"/>
               </a:rPr>
-              <a:t>    btn_chapeu.disabled = true</a:t>
+              <a:t>	btn_chapeu.disabled = true</a:t>
             </a:r>
           </a:p>
           <a:p>
             <a:pPr algn="l">
+              <a:lnSpc>
+                <a:spcPct val="100000"/>
+              </a:lnSpc>
               <a:spcBef>
                 <a:spcPts val="0"/>
               </a:spcBef>
@@ -5287,7 +5284,7 @@
               </a:spcAft>
             </a:pPr>
             <a:r>
-              <a:rPr sz="1200" b="0">
+              <a:rPr sz="1100" b="0">
                 <a:solidFill>
                   <a:srgbClr val="ECE1D1"/>
                 </a:solidFill>
@@ -5295,11 +5292,14 @@
                 <a:cs typeface="Consolas"/>
                 <a:ea typeface="Consolas"/>
               </a:rPr>
-              <a:t>    btn_chapeu.text = "Adquirido"</a:t>
+              <a:t>	btn_chapeu.text = "Adquirido"</a:t>
             </a:r>
           </a:p>
           <a:p>
             <a:pPr algn="l">
+              <a:lnSpc>
+                <a:spcPct val="100000"/>
+              </a:lnSpc>
               <a:spcBef>
                 <a:spcPts val="0"/>
               </a:spcBef>
@@ -5308,7 +5308,7 @@
               </a:spcAft>
             </a:pPr>
             <a:r>
-              <a:rPr sz="1200" b="0">
+              <a:rPr sz="1100" b="0">
                 <a:solidFill>
                   <a:srgbClr val="ECE1D1"/>
                 </a:solidFill>
@@ -5316,11 +5316,14 @@
                 <a:cs typeface="Consolas"/>
                 <a:ea typeface="Consolas"/>
               </a:rPr>
-              <a:t>    label_status.text = "Chapéu comprado!"</a:t>
+              <a:t>	label_status.text = "Chapéu comprado!"</a:t>
             </a:r>
           </a:p>
           <a:p>
             <a:pPr algn="l">
+              <a:lnSpc>
+                <a:spcPct val="100000"/>
+              </a:lnSpc>
               <a:spcBef>
                 <a:spcPts val="0"/>
               </a:spcBef>
@@ -5329,7 +5332,7 @@
               </a:spcAft>
             </a:pPr>
             <a:r>
-              <a:rPr sz="1200" b="0">
+              <a:rPr sz="1100" b="0">
                 <a:solidFill>
                   <a:srgbClr val="ECE1D1"/>
                 </a:solidFill>
@@ -5337,11 +5340,14 @@
                 <a:cs typeface="Consolas"/>
                 <a:ea typeface="Consolas"/>
               </a:rPr>
-              <a:t>    _atualizar_hud()</a:t>
+              <a:t>	_atualizar_hud()</a:t>
             </a:r>
           </a:p>
           <a:p>
             <a:pPr algn="l">
+              <a:lnSpc>
+                <a:spcPct val="100000"/>
+              </a:lnSpc>
               <a:spcBef>
                 <a:spcPts val="0"/>
               </a:spcBef>
@@ -5350,7 +5356,7 @@
               </a:spcAft>
             </a:pPr>
             <a:r>
-              <a:rPr sz="1200" b="0">
+              <a:rPr sz="1100" b="0">
                 <a:solidFill>
                   <a:srgbClr val="ECE1D1"/>
                 </a:solidFill>
@@ -5363,6 +5369,9 @@
           </a:p>
           <a:p>
             <a:pPr algn="l">
+              <a:lnSpc>
+                <a:spcPct val="100000"/>
+              </a:lnSpc>
               <a:spcBef>
                 <a:spcPts val="0"/>
               </a:spcBef>
@@ -5371,7 +5380,7 @@
               </a:spcAft>
             </a:pPr>
             <a:r>
-              <a:rPr sz="1200" b="0">
+              <a:rPr sz="1100" b="0">
                 <a:solidFill>
                   <a:srgbClr val="ECE1D1"/>
                 </a:solidFill>
@@ -5384,6 +5393,9 @@
           </a:p>
           <a:p>
             <a:pPr algn="l">
+              <a:lnSpc>
+                <a:spcPct val="100000"/>
+              </a:lnSpc>
               <a:spcBef>
                 <a:spcPts val="0"/>
               </a:spcBef>
@@ -5392,7 +5404,7 @@
               </a:spcAft>
             </a:pPr>
             <a:r>
-              <a:rPr sz="1200" b="0">
+              <a:rPr sz="1100" b="0">
                 <a:solidFill>
                   <a:srgbClr val="ECE1D1"/>
                 </a:solidFill>
@@ -5405,6 +5417,9 @@
           </a:p>
           <a:p>
             <a:pPr algn="l">
+              <a:lnSpc>
+                <a:spcPct val="100000"/>
+              </a:lnSpc>
               <a:spcBef>
                 <a:spcPts val="0"/>
               </a:spcBef>
@@ -5413,7 +5428,7 @@
               </a:spcAft>
             </a:pPr>
             <a:r>
-              <a:rPr sz="1200" b="0">
+              <a:rPr sz="1100" b="0">
                 <a:solidFill>
                   <a:srgbClr val="ECE1D1"/>
                 </a:solidFill>
@@ -5426,6 +5441,9 @@
           </a:p>
           <a:p>
             <a:pPr algn="l">
+              <a:lnSpc>
+                <a:spcPct val="100000"/>
+              </a:lnSpc>
               <a:spcBef>
                 <a:spcPts val="0"/>
               </a:spcBef>
@@ -5434,7 +5452,7 @@
               </a:spcAft>
             </a:pPr>
             <a:r>
-              <a:rPr sz="1200" b="0">
+              <a:rPr sz="1100" b="0">
                 <a:solidFill>
                   <a:srgbClr val="ECE1D1"/>
                 </a:solidFill>

</xml_diff>